<commit_message>
update powerpoint template and alignments
</commit_message>
<xml_diff>
--- a/app/template.pptx
+++ b/app/template.pptx
@@ -217,7 +217,7 @@
           <a:p>
             <a:fld id="{1024C7FB-BA89-9341-BE9C-20C3733A2A8C}" type="datetimeFigureOut">
               <a:rPr lang="nl-NL" smtClean="0"/>
-              <a:t>04-11-2023</a:t>
+              <a:t>01-03-2026</a:t>
             </a:fld>
             <a:endParaRPr lang="nl-NL"/>
           </a:p>
@@ -383,7 +383,7 @@
             <a:fld id="{12A8C541-A0A2-854F-A6FB-7CE49443EEC1}" type="datetimeFigureOut">
               <a:rPr lang="nl-NL" smtClean="0"/>
               <a:pPr/>
-              <a:t>04-11-2023</a:t>
+              <a:t>01-03-2026</a:t>
             </a:fld>
             <a:endParaRPr lang="nl-NL"/>
           </a:p>
@@ -898,7 +898,7 @@
             <a:fld id="{B01F9CA3-105E-4857-9057-6DB6197DA786}" type="datetimeFigureOut">
               <a:rPr lang="en-US" smtClean="0"/>
               <a:pPr/>
-              <a:t>11/4/23</a:t>
+              <a:t>3/1/26</a:t>
             </a:fld>
             <a:endParaRPr lang="en-US"/>
           </a:p>
@@ -996,6 +996,72 @@
           <a:prstGeom prst="rect">
             <a:avLst/>
           </a:prstGeom>
+        </p:spPr>
+      </p:pic>
+      <p:pic>
+        <p:nvPicPr>
+          <p:cNvPr id="9" name="Afbeelding 8">
+            <a:extLst>
+              <a:ext uri="{FF2B5EF4-FFF2-40B4-BE49-F238E27FC236}">
+                <a16:creationId xmlns:a16="http://schemas.microsoft.com/office/drawing/2014/main" id="{BEDE7981-F0F1-1C99-8D1E-F5AADAA37625}"/>
+              </a:ext>
+            </a:extLst>
+          </p:cNvPr>
+          <p:cNvPicPr>
+            <a:picLocks noChangeAspect="1"/>
+          </p:cNvPicPr>
+          <p:nvPr userDrawn="1"/>
+        </p:nvPicPr>
+        <p:blipFill>
+          <a:blip r:embed="rId3" cstate="print">
+            <a:extLst>
+              <a:ext uri="{28A0092B-C50C-407E-A947-70E740481C1C}">
+                <a14:useLocalDpi xmlns:a14="http://schemas.microsoft.com/office/drawing/2010/main" val="0"/>
+              </a:ext>
+            </a:extLst>
+          </a:blip>
+          <a:stretch>
+            <a:fillRect/>
+          </a:stretch>
+        </p:blipFill>
+        <p:spPr>
+          <a:xfrm>
+            <a:off x="6947282" y="209862"/>
+            <a:ext cx="1941224" cy="1294149"/>
+          </a:xfrm>
+          <a:prstGeom prst="snip2DiagRect">
+            <a:avLst/>
+          </a:prstGeom>
+          <a:solidFill>
+            <a:srgbClr val="FFFFFF">
+              <a:shade val="85000"/>
+            </a:srgbClr>
+          </a:solidFill>
+          <a:ln w="88900" cap="sq">
+            <a:solidFill>
+              <a:srgbClr val="FFFFFF"/>
+            </a:solidFill>
+            <a:miter lim="800000"/>
+          </a:ln>
+          <a:effectLst>
+            <a:outerShdw blurRad="88900" algn="tl" rotWithShape="0">
+              <a:srgbClr val="000000">
+                <a:alpha val="45000"/>
+              </a:srgbClr>
+            </a:outerShdw>
+          </a:effectLst>
+          <a:scene3d>
+            <a:camera prst="orthographicFront"/>
+            <a:lightRig rig="twoPt" dir="t">
+              <a:rot lat="0" lon="0" rev="7200000"/>
+            </a:lightRig>
+          </a:scene3d>
+          <a:sp3d>
+            <a:bevelT w="25400" h="19050"/>
+            <a:contourClr>
+              <a:srgbClr val="FFFFFF"/>
+            </a:contourClr>
+          </a:sp3d>
         </p:spPr>
       </p:pic>
     </p:spTree>
@@ -1157,7 +1223,7 @@
             <a:fld id="{B01F9CA3-105E-4857-9057-6DB6197DA786}" type="datetimeFigureOut">
               <a:rPr lang="en-US" smtClean="0"/>
               <a:pPr/>
-              <a:t>11/4/23</a:t>
+              <a:t>3/1/26</a:t>
             </a:fld>
             <a:endParaRPr lang="en-US"/>
           </a:p>
@@ -1466,7 +1532,7 @@
             <a:fld id="{B01F9CA3-105E-4857-9057-6DB6197DA786}" type="datetimeFigureOut">
               <a:rPr lang="en-US" smtClean="0"/>
               <a:pPr/>
-              <a:t>11/4/23</a:t>
+              <a:t>3/1/26</a:t>
             </a:fld>
             <a:endParaRPr lang="en-US"/>
           </a:p>
@@ -1677,7 +1743,7 @@
             <a:fld id="{B01F9CA3-105E-4857-9057-6DB6197DA786}" type="datetimeFigureOut">
               <a:rPr lang="en-US" smtClean="0"/>
               <a:pPr/>
-              <a:t>11/4/23</a:t>
+              <a:t>3/1/26</a:t>
             </a:fld>
             <a:endParaRPr lang="en-US"/>
           </a:p>
@@ -1938,7 +2004,7 @@
             <a:fld id="{B01F9CA3-105E-4857-9057-6DB6197DA786}" type="datetimeFigureOut">
               <a:rPr lang="en-US" smtClean="0"/>
               <a:pPr/>
-              <a:t>11/4/23</a:t>
+              <a:t>3/1/26</a:t>
             </a:fld>
             <a:endParaRPr lang="en-US"/>
           </a:p>
@@ -2212,7 +2278,7 @@
             <a:fld id="{B01F9CA3-105E-4857-9057-6DB6197DA786}" type="datetimeFigureOut">
               <a:rPr lang="en-US" smtClean="0"/>
               <a:pPr/>
-              <a:t>11/4/23</a:t>
+              <a:t>3/1/26</a:t>
             </a:fld>
             <a:endParaRPr lang="en-US"/>
           </a:p>
@@ -2446,7 +2512,7 @@
             <a:fld id="{B01F9CA3-105E-4857-9057-6DB6197DA786}" type="datetimeFigureOut">
               <a:rPr lang="en-US" smtClean="0"/>
               <a:pPr/>
-              <a:t>11/4/23</a:t>
+              <a:t>3/1/26</a:t>
             </a:fld>
             <a:endParaRPr lang="en-US"/>
           </a:p>
@@ -2779,7 +2845,7 @@
             <a:fld id="{B01F9CA3-105E-4857-9057-6DB6197DA786}" type="datetimeFigureOut">
               <a:rPr lang="en-US" smtClean="0"/>
               <a:pPr/>
-              <a:t>11/4/23</a:t>
+              <a:t>3/1/26</a:t>
             </a:fld>
             <a:endParaRPr lang="en-US"/>
           </a:p>
@@ -3276,7 +3342,7 @@
             <a:fld id="{B01F9CA3-105E-4857-9057-6DB6197DA786}" type="datetimeFigureOut">
               <a:rPr lang="en-US" smtClean="0"/>
               <a:pPr/>
-              <a:t>11/4/23</a:t>
+              <a:t>3/1/26</a:t>
             </a:fld>
             <a:endParaRPr lang="en-US"/>
           </a:p>
@@ -3418,7 +3484,7 @@
             <a:fld id="{B01F9CA3-105E-4857-9057-6DB6197DA786}" type="datetimeFigureOut">
               <a:rPr lang="en-US" smtClean="0"/>
               <a:pPr/>
-              <a:t>11/4/23</a:t>
+              <a:t>3/1/26</a:t>
             </a:fld>
             <a:endParaRPr lang="en-US"/>
           </a:p>
@@ -3537,7 +3603,7 @@
             <a:fld id="{B01F9CA3-105E-4857-9057-6DB6197DA786}" type="datetimeFigureOut">
               <a:rPr lang="en-US" smtClean="0"/>
               <a:pPr/>
-              <a:t>11/4/23</a:t>
+              <a:t>3/1/26</a:t>
             </a:fld>
             <a:endParaRPr lang="en-US"/>
           </a:p>
@@ -3854,7 +3920,7 @@
             <a:fld id="{B01F9CA3-105E-4857-9057-6DB6197DA786}" type="datetimeFigureOut">
               <a:rPr lang="en-US" smtClean="0"/>
               <a:pPr/>
-              <a:t>11/4/23</a:t>
+              <a:t>3/1/26</a:t>
             </a:fld>
             <a:endParaRPr lang="en-US"/>
           </a:p>

</xml_diff>